<commit_message>
first version of the GEDAI manual
</commit_message>
<xml_diff>
--- a/Manuels/picture_EEGpal_manuals.pptx
+++ b/Manuels/picture_EEGpal_manuals.pptx
@@ -5,7 +5,7 @@
     <p:sldMasterId id="2147483648" r:id="rId1"/>
   </p:sldMasterIdLst>
   <p:notesMasterIdLst>
-    <p:notesMasterId r:id="rId27"/>
+    <p:notesMasterId r:id="rId28"/>
   </p:notesMasterIdLst>
   <p:sldIdLst>
     <p:sldId id="292" r:id="rId2"/>
@@ -33,6 +33,7 @@
     <p:sldId id="297" r:id="rId24"/>
     <p:sldId id="298" r:id="rId25"/>
     <p:sldId id="300" r:id="rId26"/>
+    <p:sldId id="302" r:id="rId27"/>
   </p:sldIdLst>
   <p:sldSz cx="9144000" cy="6858000" type="screen4x3"/>
   <p:notesSz cx="6858000" cy="9144000"/>
@@ -211,6 +212,11 @@
             <p14:sldId id="300"/>
           </p14:sldIdLst>
         </p14:section>
+        <p14:section name="GEDAI" id="{E6687ACD-1E16-4652-A832-DA1A6D567172}">
+          <p14:sldIdLst>
+            <p14:sldId id="302"/>
+          </p14:sldIdLst>
+        </p14:section>
       </p14:sectionLst>
     </p:ext>
     <p:ext uri="{EFAFB233-063F-42B5-8137-9DF3F51BA10A}">
@@ -313,7 +319,7 @@
           <a:p>
             <a:fld id="{AE28F081-F961-4F1D-B0FD-EEC618487470}" type="datetimeFigureOut">
               <a:rPr lang="en-US" smtClean="0"/>
-              <a:t>9/14/2025</a:t>
+              <a:t>1/2/2026</a:t>
             </a:fld>
             <a:endParaRPr lang="en-US"/>
           </a:p>
@@ -845,7 +851,7 @@
           <a:p>
             <a:fld id="{BCB0654D-2F9E-40DC-B910-8F58A623289D}" type="datetimeFigureOut">
               <a:rPr lang="fr-CH" smtClean="0"/>
-              <a:t>14.09.2025</a:t>
+              <a:t>02.01.2026</a:t>
             </a:fld>
             <a:endParaRPr lang="fr-CH"/>
           </a:p>
@@ -1015,7 +1021,7 @@
           <a:p>
             <a:fld id="{BCB0654D-2F9E-40DC-B910-8F58A623289D}" type="datetimeFigureOut">
               <a:rPr lang="fr-CH" smtClean="0"/>
-              <a:t>14.09.2025</a:t>
+              <a:t>02.01.2026</a:t>
             </a:fld>
             <a:endParaRPr lang="fr-CH"/>
           </a:p>
@@ -1195,7 +1201,7 @@
           <a:p>
             <a:fld id="{BCB0654D-2F9E-40DC-B910-8F58A623289D}" type="datetimeFigureOut">
               <a:rPr lang="fr-CH" smtClean="0"/>
-              <a:t>14.09.2025</a:t>
+              <a:t>02.01.2026</a:t>
             </a:fld>
             <a:endParaRPr lang="fr-CH"/>
           </a:p>
@@ -1365,7 +1371,7 @@
           <a:p>
             <a:fld id="{BCB0654D-2F9E-40DC-B910-8F58A623289D}" type="datetimeFigureOut">
               <a:rPr lang="fr-CH" smtClean="0"/>
-              <a:t>14.09.2025</a:t>
+              <a:t>02.01.2026</a:t>
             </a:fld>
             <a:endParaRPr lang="fr-CH"/>
           </a:p>
@@ -1611,7 +1617,7 @@
           <a:p>
             <a:fld id="{BCB0654D-2F9E-40DC-B910-8F58A623289D}" type="datetimeFigureOut">
               <a:rPr lang="fr-CH" smtClean="0"/>
-              <a:t>14.09.2025</a:t>
+              <a:t>02.01.2026</a:t>
             </a:fld>
             <a:endParaRPr lang="fr-CH"/>
           </a:p>
@@ -1899,7 +1905,7 @@
           <a:p>
             <a:fld id="{BCB0654D-2F9E-40DC-B910-8F58A623289D}" type="datetimeFigureOut">
               <a:rPr lang="fr-CH" smtClean="0"/>
-              <a:t>14.09.2025</a:t>
+              <a:t>02.01.2026</a:t>
             </a:fld>
             <a:endParaRPr lang="fr-CH"/>
           </a:p>
@@ -2321,7 +2327,7 @@
           <a:p>
             <a:fld id="{BCB0654D-2F9E-40DC-B910-8F58A623289D}" type="datetimeFigureOut">
               <a:rPr lang="fr-CH" smtClean="0"/>
-              <a:t>14.09.2025</a:t>
+              <a:t>02.01.2026</a:t>
             </a:fld>
             <a:endParaRPr lang="fr-CH"/>
           </a:p>
@@ -2439,7 +2445,7 @@
           <a:p>
             <a:fld id="{BCB0654D-2F9E-40DC-B910-8F58A623289D}" type="datetimeFigureOut">
               <a:rPr lang="fr-CH" smtClean="0"/>
-              <a:t>14.09.2025</a:t>
+              <a:t>02.01.2026</a:t>
             </a:fld>
             <a:endParaRPr lang="fr-CH"/>
           </a:p>
@@ -2534,7 +2540,7 @@
           <a:p>
             <a:fld id="{BCB0654D-2F9E-40DC-B910-8F58A623289D}" type="datetimeFigureOut">
               <a:rPr lang="fr-CH" smtClean="0"/>
-              <a:t>14.09.2025</a:t>
+              <a:t>02.01.2026</a:t>
             </a:fld>
             <a:endParaRPr lang="fr-CH"/>
           </a:p>
@@ -2811,7 +2817,7 @@
           <a:p>
             <a:fld id="{BCB0654D-2F9E-40DC-B910-8F58A623289D}" type="datetimeFigureOut">
               <a:rPr lang="fr-CH" smtClean="0"/>
-              <a:t>14.09.2025</a:t>
+              <a:t>02.01.2026</a:t>
             </a:fld>
             <a:endParaRPr lang="fr-CH"/>
           </a:p>
@@ -3064,7 +3070,7 @@
           <a:p>
             <a:fld id="{BCB0654D-2F9E-40DC-B910-8F58A623289D}" type="datetimeFigureOut">
               <a:rPr lang="fr-CH" smtClean="0"/>
-              <a:t>14.09.2025</a:t>
+              <a:t>02.01.2026</a:t>
             </a:fld>
             <a:endParaRPr lang="fr-CH"/>
           </a:p>
@@ -3277,7 +3283,7 @@
           <a:p>
             <a:fld id="{BCB0654D-2F9E-40DC-B910-8F58A623289D}" type="datetimeFigureOut">
               <a:rPr lang="fr-CH" smtClean="0"/>
-              <a:t>14.09.2025</a:t>
+              <a:t>02.01.2026</a:t>
             </a:fld>
             <a:endParaRPr lang="fr-CH"/>
           </a:p>
@@ -15378,6 +15384,640 @@
     <p:extLst>
       <p:ext uri="{BB962C8B-B14F-4D97-AF65-F5344CB8AC3E}">
         <p14:creationId xmlns:p14="http://schemas.microsoft.com/office/powerpoint/2010/main" val="2750009283"/>
+      </p:ext>
+    </p:extLst>
+  </p:cSld>
+  <p:clrMapOvr>
+    <a:masterClrMapping/>
+  </p:clrMapOvr>
+</p:sld>
+</file>
+
+<file path=ppt/slides/slide26.xml><?xml version="1.0" encoding="utf-8"?>
+<p:sld xmlns:a="http://schemas.openxmlformats.org/drawingml/2006/main" xmlns:r="http://schemas.openxmlformats.org/officeDocument/2006/relationships" xmlns:p="http://schemas.openxmlformats.org/presentationml/2006/main">
+  <p:cSld>
+    <p:spTree>
+      <p:nvGrpSpPr>
+        <p:cNvPr id="1" name=""/>
+        <p:cNvGrpSpPr/>
+        <p:nvPr/>
+      </p:nvGrpSpPr>
+      <p:grpSpPr>
+        <a:xfrm>
+          <a:off x="0" y="0"/>
+          <a:ext cx="0" cy="0"/>
+          <a:chOff x="0" y="0"/>
+          <a:chExt cx="0" cy="0"/>
+        </a:xfrm>
+      </p:grpSpPr>
+      <p:pic>
+        <p:nvPicPr>
+          <p:cNvPr id="5" name="Picture 4" descr="A screenshot of a computer&#10;&#10;AI-generated content may be incorrect.">
+            <a:extLst>
+              <a:ext uri="{FF2B5EF4-FFF2-40B4-BE49-F238E27FC236}">
+                <a16:creationId xmlns:a16="http://schemas.microsoft.com/office/drawing/2014/main" id="{F935D67B-9FB9-F2B7-9BFA-DF727780DB83}"/>
+              </a:ext>
+            </a:extLst>
+          </p:cNvPr>
+          <p:cNvPicPr>
+            <a:picLocks noChangeAspect="1"/>
+          </p:cNvPicPr>
+          <p:nvPr/>
+        </p:nvPicPr>
+        <p:blipFill>
+          <a:blip r:embed="rId2"/>
+          <a:stretch>
+            <a:fillRect/>
+          </a:stretch>
+        </p:blipFill>
+        <p:spPr>
+          <a:xfrm>
+            <a:off x="1628965" y="1118616"/>
+            <a:ext cx="5648325" cy="3962400"/>
+          </a:xfrm>
+          <a:prstGeom prst="rect">
+            <a:avLst/>
+          </a:prstGeom>
+        </p:spPr>
+      </p:pic>
+      <p:sp>
+        <p:nvSpPr>
+          <p:cNvPr id="6" name="ZoneTexte 6">
+            <a:extLst>
+              <a:ext uri="{FF2B5EF4-FFF2-40B4-BE49-F238E27FC236}">
+                <a16:creationId xmlns:a16="http://schemas.microsoft.com/office/drawing/2014/main" id="{E1832966-5DC6-FCBA-6CDB-9D700CADA8D7}"/>
+              </a:ext>
+            </a:extLst>
+          </p:cNvPr>
+          <p:cNvSpPr txBox="1"/>
+          <p:nvPr/>
+        </p:nvSpPr>
+        <p:spPr>
+          <a:xfrm>
+            <a:off x="4682910" y="1972390"/>
+            <a:ext cx="301686" cy="369332"/>
+          </a:xfrm>
+          <a:prstGeom prst="rect">
+            <a:avLst/>
+          </a:prstGeom>
+          <a:noFill/>
+        </p:spPr>
+        <p:txBody>
+          <a:bodyPr wrap="none" rtlCol="0">
+            <a:spAutoFit/>
+          </a:bodyPr>
+          <a:lstStyle/>
+          <a:p>
+            <a:r>
+              <a:rPr lang="fr-CH" dirty="0"/>
+              <a:t>1</a:t>
+            </a:r>
+          </a:p>
+        </p:txBody>
+      </p:sp>
+      <p:sp>
+        <p:nvSpPr>
+          <p:cNvPr id="7" name="ZoneTexte 6">
+            <a:extLst>
+              <a:ext uri="{FF2B5EF4-FFF2-40B4-BE49-F238E27FC236}">
+                <a16:creationId xmlns:a16="http://schemas.microsoft.com/office/drawing/2014/main" id="{BC11E403-9139-7336-E47C-D359456FEF21}"/>
+              </a:ext>
+            </a:extLst>
+          </p:cNvPr>
+          <p:cNvSpPr txBox="1"/>
+          <p:nvPr/>
+        </p:nvSpPr>
+        <p:spPr>
+          <a:xfrm>
+            <a:off x="4692054" y="2762346"/>
+            <a:ext cx="301686" cy="369332"/>
+          </a:xfrm>
+          <a:prstGeom prst="rect">
+            <a:avLst/>
+          </a:prstGeom>
+          <a:noFill/>
+        </p:spPr>
+        <p:txBody>
+          <a:bodyPr wrap="none" rtlCol="0">
+            <a:spAutoFit/>
+          </a:bodyPr>
+          <a:lstStyle/>
+          <a:p>
+            <a:r>
+              <a:rPr lang="fr-CH" dirty="0"/>
+              <a:t>3</a:t>
+            </a:r>
+          </a:p>
+        </p:txBody>
+      </p:sp>
+      <p:sp>
+        <p:nvSpPr>
+          <p:cNvPr id="8" name="ZoneTexte 6">
+            <a:extLst>
+              <a:ext uri="{FF2B5EF4-FFF2-40B4-BE49-F238E27FC236}">
+                <a16:creationId xmlns:a16="http://schemas.microsoft.com/office/drawing/2014/main" id="{AD081513-4081-66AE-CE83-6F1306AEC5C2}"/>
+              </a:ext>
+            </a:extLst>
+          </p:cNvPr>
+          <p:cNvSpPr txBox="1"/>
+          <p:nvPr/>
+        </p:nvSpPr>
+        <p:spPr>
+          <a:xfrm>
+            <a:off x="4692054" y="2393014"/>
+            <a:ext cx="301686" cy="369332"/>
+          </a:xfrm>
+          <a:prstGeom prst="rect">
+            <a:avLst/>
+          </a:prstGeom>
+          <a:noFill/>
+        </p:spPr>
+        <p:txBody>
+          <a:bodyPr wrap="none" rtlCol="0">
+            <a:spAutoFit/>
+          </a:bodyPr>
+          <a:lstStyle/>
+          <a:p>
+            <a:r>
+              <a:rPr lang="fr-CH" dirty="0"/>
+              <a:t>2</a:t>
+            </a:r>
+          </a:p>
+        </p:txBody>
+      </p:sp>
+      <p:sp>
+        <p:nvSpPr>
+          <p:cNvPr id="9" name="ZoneTexte 6">
+            <a:extLst>
+              <a:ext uri="{FF2B5EF4-FFF2-40B4-BE49-F238E27FC236}">
+                <a16:creationId xmlns:a16="http://schemas.microsoft.com/office/drawing/2014/main" id="{94A2177C-5B9C-5F27-FED6-42B6ABE2D9D4}"/>
+              </a:ext>
+            </a:extLst>
+          </p:cNvPr>
+          <p:cNvSpPr txBox="1"/>
+          <p:nvPr/>
+        </p:nvSpPr>
+        <p:spPr>
+          <a:xfrm>
+            <a:off x="4692054" y="3127153"/>
+            <a:ext cx="301686" cy="369332"/>
+          </a:xfrm>
+          <a:prstGeom prst="rect">
+            <a:avLst/>
+          </a:prstGeom>
+          <a:noFill/>
+        </p:spPr>
+        <p:txBody>
+          <a:bodyPr wrap="none" rtlCol="0">
+            <a:spAutoFit/>
+          </a:bodyPr>
+          <a:lstStyle/>
+          <a:p>
+            <a:r>
+              <a:rPr lang="fr-CH" dirty="0"/>
+              <a:t>4</a:t>
+            </a:r>
+          </a:p>
+        </p:txBody>
+      </p:sp>
+      <p:sp>
+        <p:nvSpPr>
+          <p:cNvPr id="10" name="ZoneTexte 6">
+            <a:extLst>
+              <a:ext uri="{FF2B5EF4-FFF2-40B4-BE49-F238E27FC236}">
+                <a16:creationId xmlns:a16="http://schemas.microsoft.com/office/drawing/2014/main" id="{FBB587CF-9555-E92A-2555-04AA60F66F7F}"/>
+              </a:ext>
+            </a:extLst>
+          </p:cNvPr>
+          <p:cNvSpPr txBox="1"/>
+          <p:nvPr/>
+        </p:nvSpPr>
+        <p:spPr>
+          <a:xfrm>
+            <a:off x="7071583" y="1846090"/>
+            <a:ext cx="301686" cy="369332"/>
+          </a:xfrm>
+          <a:prstGeom prst="rect">
+            <a:avLst/>
+          </a:prstGeom>
+          <a:noFill/>
+        </p:spPr>
+        <p:txBody>
+          <a:bodyPr wrap="none" rtlCol="0">
+            <a:spAutoFit/>
+          </a:bodyPr>
+          <a:lstStyle/>
+          <a:p>
+            <a:r>
+              <a:rPr lang="fr-CH" dirty="0"/>
+              <a:t>6</a:t>
+            </a:r>
+          </a:p>
+        </p:txBody>
+      </p:sp>
+      <p:sp>
+        <p:nvSpPr>
+          <p:cNvPr id="11" name="ZoneTexte 6">
+            <a:extLst>
+              <a:ext uri="{FF2B5EF4-FFF2-40B4-BE49-F238E27FC236}">
+                <a16:creationId xmlns:a16="http://schemas.microsoft.com/office/drawing/2014/main" id="{1230193B-1B22-A38F-07C9-550E2CC88CEA}"/>
+              </a:ext>
+            </a:extLst>
+          </p:cNvPr>
+          <p:cNvSpPr txBox="1"/>
+          <p:nvPr/>
+        </p:nvSpPr>
+        <p:spPr>
+          <a:xfrm>
+            <a:off x="7071583" y="2393014"/>
+            <a:ext cx="301686" cy="369332"/>
+          </a:xfrm>
+          <a:prstGeom prst="rect">
+            <a:avLst/>
+          </a:prstGeom>
+          <a:noFill/>
+        </p:spPr>
+        <p:txBody>
+          <a:bodyPr wrap="none" rtlCol="0">
+            <a:spAutoFit/>
+          </a:bodyPr>
+          <a:lstStyle/>
+          <a:p>
+            <a:r>
+              <a:rPr lang="fr-CH" dirty="0"/>
+              <a:t>7</a:t>
+            </a:r>
+          </a:p>
+        </p:txBody>
+      </p:sp>
+      <p:sp>
+        <p:nvSpPr>
+          <p:cNvPr id="12" name="ZoneTexte 6">
+            <a:extLst>
+              <a:ext uri="{FF2B5EF4-FFF2-40B4-BE49-F238E27FC236}">
+                <a16:creationId xmlns:a16="http://schemas.microsoft.com/office/drawing/2014/main" id="{E37F6060-A47F-B8BD-78F1-37BEEE9649CF}"/>
+              </a:ext>
+            </a:extLst>
+          </p:cNvPr>
+          <p:cNvSpPr txBox="1"/>
+          <p:nvPr/>
+        </p:nvSpPr>
+        <p:spPr>
+          <a:xfrm>
+            <a:off x="4693170" y="3861292"/>
+            <a:ext cx="301686" cy="369332"/>
+          </a:xfrm>
+          <a:prstGeom prst="rect">
+            <a:avLst/>
+          </a:prstGeom>
+          <a:noFill/>
+        </p:spPr>
+        <p:txBody>
+          <a:bodyPr wrap="none" rtlCol="0">
+            <a:spAutoFit/>
+          </a:bodyPr>
+          <a:lstStyle/>
+          <a:p>
+            <a:r>
+              <a:rPr lang="fr-CH" dirty="0"/>
+              <a:t>5</a:t>
+            </a:r>
+          </a:p>
+        </p:txBody>
+      </p:sp>
+      <p:sp>
+        <p:nvSpPr>
+          <p:cNvPr id="13" name="ZoneTexte 6">
+            <a:extLst>
+              <a:ext uri="{FF2B5EF4-FFF2-40B4-BE49-F238E27FC236}">
+                <a16:creationId xmlns:a16="http://schemas.microsoft.com/office/drawing/2014/main" id="{43E622FE-5561-63F1-62F7-6DE0B5C5DBDC}"/>
+              </a:ext>
+            </a:extLst>
+          </p:cNvPr>
+          <p:cNvSpPr txBox="1"/>
+          <p:nvPr/>
+        </p:nvSpPr>
+        <p:spPr>
+          <a:xfrm>
+            <a:off x="3806202" y="4455652"/>
+            <a:ext cx="301686" cy="369332"/>
+          </a:xfrm>
+          <a:prstGeom prst="rect">
+            <a:avLst/>
+          </a:prstGeom>
+          <a:noFill/>
+        </p:spPr>
+        <p:txBody>
+          <a:bodyPr wrap="none" rtlCol="0">
+            <a:spAutoFit/>
+          </a:bodyPr>
+          <a:lstStyle/>
+          <a:p>
+            <a:r>
+              <a:rPr lang="fr-CH" dirty="0"/>
+              <a:t>6</a:t>
+            </a:r>
+          </a:p>
+        </p:txBody>
+      </p:sp>
+      <p:sp>
+        <p:nvSpPr>
+          <p:cNvPr id="14" name="ZoneTexte 6">
+            <a:extLst>
+              <a:ext uri="{FF2B5EF4-FFF2-40B4-BE49-F238E27FC236}">
+                <a16:creationId xmlns:a16="http://schemas.microsoft.com/office/drawing/2014/main" id="{0A0A402F-7828-2B83-1FB5-91C713E03C1D}"/>
+              </a:ext>
+            </a:extLst>
+          </p:cNvPr>
+          <p:cNvSpPr txBox="1"/>
+          <p:nvPr/>
+        </p:nvSpPr>
+        <p:spPr>
+          <a:xfrm>
+            <a:off x="3806202" y="4731758"/>
+            <a:ext cx="301686" cy="369332"/>
+          </a:xfrm>
+          <a:prstGeom prst="rect">
+            <a:avLst/>
+          </a:prstGeom>
+          <a:noFill/>
+        </p:spPr>
+        <p:txBody>
+          <a:bodyPr wrap="none" rtlCol="0">
+            <a:spAutoFit/>
+          </a:bodyPr>
+          <a:lstStyle/>
+          <a:p>
+            <a:r>
+              <a:rPr lang="fr-CH" dirty="0"/>
+              <a:t>7</a:t>
+            </a:r>
+          </a:p>
+        </p:txBody>
+      </p:sp>
+      <p:sp>
+        <p:nvSpPr>
+          <p:cNvPr id="15" name="ZoneTexte 6">
+            <a:extLst>
+              <a:ext uri="{FF2B5EF4-FFF2-40B4-BE49-F238E27FC236}">
+                <a16:creationId xmlns:a16="http://schemas.microsoft.com/office/drawing/2014/main" id="{55622F88-92E8-06FC-F716-27EB55B8718D}"/>
+              </a:ext>
+            </a:extLst>
+          </p:cNvPr>
+          <p:cNvSpPr txBox="1"/>
+          <p:nvPr/>
+        </p:nvSpPr>
+        <p:spPr>
+          <a:xfrm>
+            <a:off x="7080727" y="3099816"/>
+            <a:ext cx="301686" cy="369332"/>
+          </a:xfrm>
+          <a:prstGeom prst="rect">
+            <a:avLst/>
+          </a:prstGeom>
+          <a:noFill/>
+        </p:spPr>
+        <p:txBody>
+          <a:bodyPr wrap="none" rtlCol="0">
+            <a:spAutoFit/>
+          </a:bodyPr>
+          <a:lstStyle/>
+          <a:p>
+            <a:r>
+              <a:rPr lang="fr-FR" dirty="0"/>
+              <a:t>8</a:t>
+            </a:r>
+            <a:endParaRPr lang="fr-CH" dirty="0"/>
+          </a:p>
+        </p:txBody>
+      </p:sp>
+      <p:sp>
+        <p:nvSpPr>
+          <p:cNvPr id="16" name="ZoneTexte 6">
+            <a:extLst>
+              <a:ext uri="{FF2B5EF4-FFF2-40B4-BE49-F238E27FC236}">
+                <a16:creationId xmlns:a16="http://schemas.microsoft.com/office/drawing/2014/main" id="{A083FEB7-4089-67CC-F214-90806BDCC29D}"/>
+              </a:ext>
+            </a:extLst>
+          </p:cNvPr>
+          <p:cNvSpPr txBox="1"/>
+          <p:nvPr/>
+        </p:nvSpPr>
+        <p:spPr>
+          <a:xfrm>
+            <a:off x="5436958" y="3429000"/>
+            <a:ext cx="301686" cy="369332"/>
+          </a:xfrm>
+          <a:prstGeom prst="rect">
+            <a:avLst/>
+          </a:prstGeom>
+          <a:noFill/>
+        </p:spPr>
+        <p:txBody>
+          <a:bodyPr wrap="none" rtlCol="0">
+            <a:spAutoFit/>
+          </a:bodyPr>
+          <a:lstStyle/>
+          <a:p>
+            <a:r>
+              <a:rPr lang="fr-CH" dirty="0"/>
+              <a:t>9</a:t>
+            </a:r>
+          </a:p>
+        </p:txBody>
+      </p:sp>
+      <p:sp>
+        <p:nvSpPr>
+          <p:cNvPr id="17" name="Rectangle 16">
+            <a:extLst>
+              <a:ext uri="{FF2B5EF4-FFF2-40B4-BE49-F238E27FC236}">
+                <a16:creationId xmlns:a16="http://schemas.microsoft.com/office/drawing/2014/main" id="{161A0106-38AB-0C07-1D23-B074714DF9F8}"/>
+              </a:ext>
+            </a:extLst>
+          </p:cNvPr>
+          <p:cNvSpPr/>
+          <p:nvPr/>
+        </p:nvSpPr>
+        <p:spPr>
+          <a:xfrm>
+            <a:off x="1628965" y="1908161"/>
+            <a:ext cx="3290507" cy="3172855"/>
+          </a:xfrm>
+          <a:prstGeom prst="rect">
+            <a:avLst/>
+          </a:prstGeom>
+          <a:noFill/>
+          <a:ln w="28575" cap="flat" cmpd="sng" algn="ctr">
+            <a:solidFill>
+              <a:srgbClr val="FF0000"/>
+            </a:solidFill>
+            <a:prstDash val="solid"/>
+            <a:round/>
+            <a:headEnd type="none" w="med" len="med"/>
+            <a:tailEnd type="none" w="med" len="med"/>
+          </a:ln>
+        </p:spPr>
+        <p:style>
+          <a:lnRef idx="0">
+            <a:scrgbClr r="0" g="0" b="0"/>
+          </a:lnRef>
+          <a:fillRef idx="0">
+            <a:scrgbClr r="0" g="0" b="0"/>
+          </a:fillRef>
+          <a:effectRef idx="0">
+            <a:scrgbClr r="0" g="0" b="0"/>
+          </a:effectRef>
+          <a:fontRef idx="minor">
+            <a:schemeClr val="accent6"/>
+          </a:fontRef>
+        </p:style>
+        <p:txBody>
+          <a:bodyPr rtlCol="0" anchor="ctr"/>
+          <a:lstStyle/>
+          <a:p>
+            <a:pPr algn="ctr"/>
+            <a:endParaRPr lang="en-US"/>
+          </a:p>
+        </p:txBody>
+      </p:sp>
+      <p:sp>
+        <p:nvSpPr>
+          <p:cNvPr id="18" name="TextBox 17">
+            <a:extLst>
+              <a:ext uri="{FF2B5EF4-FFF2-40B4-BE49-F238E27FC236}">
+                <a16:creationId xmlns:a16="http://schemas.microsoft.com/office/drawing/2014/main" id="{7EAFEDC0-A640-78A4-93AF-69F472B6124F}"/>
+              </a:ext>
+            </a:extLst>
+          </p:cNvPr>
+          <p:cNvSpPr txBox="1"/>
+          <p:nvPr/>
+        </p:nvSpPr>
+        <p:spPr>
+          <a:xfrm>
+            <a:off x="1311249" y="1972390"/>
+            <a:ext cx="317716" cy="369332"/>
+          </a:xfrm>
+          <a:prstGeom prst="rect">
+            <a:avLst/>
+          </a:prstGeom>
+          <a:noFill/>
+        </p:spPr>
+        <p:txBody>
+          <a:bodyPr wrap="none" rtlCol="0">
+            <a:spAutoFit/>
+          </a:bodyPr>
+          <a:lstStyle/>
+          <a:p>
+            <a:r>
+              <a:rPr lang="en-US" dirty="0">
+                <a:solidFill>
+                  <a:srgbClr val="FF0000"/>
+                </a:solidFill>
+              </a:rPr>
+              <a:t>A</a:t>
+            </a:r>
+          </a:p>
+        </p:txBody>
+      </p:sp>
+      <p:sp>
+        <p:nvSpPr>
+          <p:cNvPr id="19" name="Rectangle 18">
+            <a:extLst>
+              <a:ext uri="{FF2B5EF4-FFF2-40B4-BE49-F238E27FC236}">
+                <a16:creationId xmlns:a16="http://schemas.microsoft.com/office/drawing/2014/main" id="{1AE3E50C-871E-3E6E-654C-885E2C7AB0A6}"/>
+              </a:ext>
+            </a:extLst>
+          </p:cNvPr>
+          <p:cNvSpPr/>
+          <p:nvPr/>
+        </p:nvSpPr>
+        <p:spPr>
+          <a:xfrm>
+            <a:off x="4928584" y="1908161"/>
+            <a:ext cx="2348706" cy="2322463"/>
+          </a:xfrm>
+          <a:prstGeom prst="rect">
+            <a:avLst/>
+          </a:prstGeom>
+          <a:noFill/>
+          <a:ln>
+            <a:solidFill>
+              <a:schemeClr val="accent1">
+                <a:lumMod val="75000"/>
+              </a:schemeClr>
+            </a:solidFill>
+          </a:ln>
+        </p:spPr>
+        <p:style>
+          <a:lnRef idx="2">
+            <a:schemeClr val="accent1">
+              <a:shade val="50000"/>
+            </a:schemeClr>
+          </a:lnRef>
+          <a:fillRef idx="1">
+            <a:schemeClr val="accent1"/>
+          </a:fillRef>
+          <a:effectRef idx="0">
+            <a:schemeClr val="accent1"/>
+          </a:effectRef>
+          <a:fontRef idx="minor">
+            <a:schemeClr val="lt1"/>
+          </a:fontRef>
+        </p:style>
+        <p:txBody>
+          <a:bodyPr rtlCol="0" anchor="ctr"/>
+          <a:lstStyle/>
+          <a:p>
+            <a:pPr algn="ctr"/>
+            <a:endParaRPr lang="fr-CH"/>
+          </a:p>
+        </p:txBody>
+      </p:sp>
+      <p:sp>
+        <p:nvSpPr>
+          <p:cNvPr id="20" name="TextBox 19">
+            <a:extLst>
+              <a:ext uri="{FF2B5EF4-FFF2-40B4-BE49-F238E27FC236}">
+                <a16:creationId xmlns:a16="http://schemas.microsoft.com/office/drawing/2014/main" id="{55B5B0CA-5C6D-52BE-F98C-0EC44E238CE7}"/>
+              </a:ext>
+            </a:extLst>
+          </p:cNvPr>
+          <p:cNvSpPr txBox="1"/>
+          <p:nvPr/>
+        </p:nvSpPr>
+        <p:spPr>
+          <a:xfrm>
+            <a:off x="7286402" y="1830159"/>
+            <a:ext cx="317716" cy="369332"/>
+          </a:xfrm>
+          <a:prstGeom prst="rect">
+            <a:avLst/>
+          </a:prstGeom>
+          <a:noFill/>
+        </p:spPr>
+        <p:txBody>
+          <a:bodyPr wrap="none" rtlCol="0">
+            <a:spAutoFit/>
+          </a:bodyPr>
+          <a:lstStyle/>
+          <a:p>
+            <a:r>
+              <a:rPr lang="en-US" dirty="0">
+                <a:solidFill>
+                  <a:schemeClr val="accent5">
+                    <a:lumMod val="75000"/>
+                  </a:schemeClr>
+                </a:solidFill>
+              </a:rPr>
+              <a:t>B</a:t>
+            </a:r>
+          </a:p>
+        </p:txBody>
+      </p:sp>
+    </p:spTree>
+    <p:extLst>
+      <p:ext uri="{BB962C8B-B14F-4D97-AF65-F5344CB8AC3E}">
+        <p14:creationId xmlns:p14="http://schemas.microsoft.com/office/powerpoint/2010/main" val="3623933076"/>
       </p:ext>
     </p:extLst>
   </p:cSld>

</xml_diff>

<commit_message>
Modification of the Main EEGpal layout
</commit_message>
<xml_diff>
--- a/Manuels/picture_EEGpal_manuals.pptx
+++ b/Manuels/picture_EEGpal_manuals.pptx
@@ -319,7 +319,7 @@
           <a:p>
             <a:fld id="{AE28F081-F961-4F1D-B0FD-EEC618487470}" type="datetimeFigureOut">
               <a:rPr lang="en-US" smtClean="0"/>
-              <a:t>1/2/2026</a:t>
+              <a:t>1/4/2026</a:t>
             </a:fld>
             <a:endParaRPr lang="en-US"/>
           </a:p>
@@ -851,7 +851,7 @@
           <a:p>
             <a:fld id="{BCB0654D-2F9E-40DC-B910-8F58A623289D}" type="datetimeFigureOut">
               <a:rPr lang="fr-CH" smtClean="0"/>
-              <a:t>02.01.2026</a:t>
+              <a:t>04.01.2026</a:t>
             </a:fld>
             <a:endParaRPr lang="fr-CH"/>
           </a:p>
@@ -1021,7 +1021,7 @@
           <a:p>
             <a:fld id="{BCB0654D-2F9E-40DC-B910-8F58A623289D}" type="datetimeFigureOut">
               <a:rPr lang="fr-CH" smtClean="0"/>
-              <a:t>02.01.2026</a:t>
+              <a:t>04.01.2026</a:t>
             </a:fld>
             <a:endParaRPr lang="fr-CH"/>
           </a:p>
@@ -1201,7 +1201,7 @@
           <a:p>
             <a:fld id="{BCB0654D-2F9E-40DC-B910-8F58A623289D}" type="datetimeFigureOut">
               <a:rPr lang="fr-CH" smtClean="0"/>
-              <a:t>02.01.2026</a:t>
+              <a:t>04.01.2026</a:t>
             </a:fld>
             <a:endParaRPr lang="fr-CH"/>
           </a:p>
@@ -1371,7 +1371,7 @@
           <a:p>
             <a:fld id="{BCB0654D-2F9E-40DC-B910-8F58A623289D}" type="datetimeFigureOut">
               <a:rPr lang="fr-CH" smtClean="0"/>
-              <a:t>02.01.2026</a:t>
+              <a:t>04.01.2026</a:t>
             </a:fld>
             <a:endParaRPr lang="fr-CH"/>
           </a:p>
@@ -1617,7 +1617,7 @@
           <a:p>
             <a:fld id="{BCB0654D-2F9E-40DC-B910-8F58A623289D}" type="datetimeFigureOut">
               <a:rPr lang="fr-CH" smtClean="0"/>
-              <a:t>02.01.2026</a:t>
+              <a:t>04.01.2026</a:t>
             </a:fld>
             <a:endParaRPr lang="fr-CH"/>
           </a:p>
@@ -1905,7 +1905,7 @@
           <a:p>
             <a:fld id="{BCB0654D-2F9E-40DC-B910-8F58A623289D}" type="datetimeFigureOut">
               <a:rPr lang="fr-CH" smtClean="0"/>
-              <a:t>02.01.2026</a:t>
+              <a:t>04.01.2026</a:t>
             </a:fld>
             <a:endParaRPr lang="fr-CH"/>
           </a:p>
@@ -2327,7 +2327,7 @@
           <a:p>
             <a:fld id="{BCB0654D-2F9E-40DC-B910-8F58A623289D}" type="datetimeFigureOut">
               <a:rPr lang="fr-CH" smtClean="0"/>
-              <a:t>02.01.2026</a:t>
+              <a:t>04.01.2026</a:t>
             </a:fld>
             <a:endParaRPr lang="fr-CH"/>
           </a:p>
@@ -2445,7 +2445,7 @@
           <a:p>
             <a:fld id="{BCB0654D-2F9E-40DC-B910-8F58A623289D}" type="datetimeFigureOut">
               <a:rPr lang="fr-CH" smtClean="0"/>
-              <a:t>02.01.2026</a:t>
+              <a:t>04.01.2026</a:t>
             </a:fld>
             <a:endParaRPr lang="fr-CH"/>
           </a:p>
@@ -2540,7 +2540,7 @@
           <a:p>
             <a:fld id="{BCB0654D-2F9E-40DC-B910-8F58A623289D}" type="datetimeFigureOut">
               <a:rPr lang="fr-CH" smtClean="0"/>
-              <a:t>02.01.2026</a:t>
+              <a:t>04.01.2026</a:t>
             </a:fld>
             <a:endParaRPr lang="fr-CH"/>
           </a:p>
@@ -2817,7 +2817,7 @@
           <a:p>
             <a:fld id="{BCB0654D-2F9E-40DC-B910-8F58A623289D}" type="datetimeFigureOut">
               <a:rPr lang="fr-CH" smtClean="0"/>
-              <a:t>02.01.2026</a:t>
+              <a:t>04.01.2026</a:t>
             </a:fld>
             <a:endParaRPr lang="fr-CH"/>
           </a:p>
@@ -3070,7 +3070,7 @@
           <a:p>
             <a:fld id="{BCB0654D-2F9E-40DC-B910-8F58A623289D}" type="datetimeFigureOut">
               <a:rPr lang="fr-CH" smtClean="0"/>
-              <a:t>02.01.2026</a:t>
+              <a:t>04.01.2026</a:t>
             </a:fld>
             <a:endParaRPr lang="fr-CH"/>
           </a:p>
@@ -3283,7 +3283,7 @@
           <a:p>
             <a:fld id="{BCB0654D-2F9E-40DC-B910-8F58A623289D}" type="datetimeFigureOut">
               <a:rPr lang="fr-CH" smtClean="0"/>
-              <a:t>02.01.2026</a:t>
+              <a:t>04.01.2026</a:t>
             </a:fld>
             <a:endParaRPr lang="fr-CH"/>
           </a:p>
@@ -15412,10 +15412,10 @@
       </p:grpSpPr>
       <p:pic>
         <p:nvPicPr>
-          <p:cNvPr id="5" name="Picture 4" descr="A screenshot of a computer&#10;&#10;AI-generated content may be incorrect.">
-            <a:extLst>
-              <a:ext uri="{FF2B5EF4-FFF2-40B4-BE49-F238E27FC236}">
-                <a16:creationId xmlns:a16="http://schemas.microsoft.com/office/drawing/2014/main" id="{F935D67B-9FB9-F2B7-9BFA-DF727780DB83}"/>
+          <p:cNvPr id="3" name="Picture 2" descr="A screenshot of a computer&#10;&#10;AI-generated content may be incorrect.">
+            <a:extLst>
+              <a:ext uri="{FF2B5EF4-FFF2-40B4-BE49-F238E27FC236}">
+                <a16:creationId xmlns:a16="http://schemas.microsoft.com/office/drawing/2014/main" id="{F02B39B6-4AD2-B020-8FE4-77C7ABD0E34D}"/>
               </a:ext>
             </a:extLst>
           </p:cNvPr>
@@ -15432,7 +15432,7 @@
         </p:blipFill>
         <p:spPr>
           <a:xfrm>
-            <a:off x="1628965" y="1118616"/>
+            <a:off x="1619853" y="1118616"/>
             <a:ext cx="5648325" cy="3962400"/>
           </a:xfrm>
           <a:prstGeom prst="rect">

</xml_diff>